<commit_message>
feat(deck): bilingual pass — a Thai term beside each domain term
Six slides carried no Thai at all: the macro overlay, conditions,
registration windows, brand concentration, the second-hand market and
the collateral divider. Nine glosses added on the terms a Thai-speaking
room actually uses — หนี้ครัวเรือน, กำลังแรงงาน, นอกระบบ, ภัยแล้ง,
กันชนทางการเงิน, หนี้เสีย, รถกระบะ, รถยนต์นั่ง, รถจักรยานยนต์.

One gloss per term per slide, on its most prominent use, rather than
everywhere it appears — the standing instruction is fewer words, and a
term repeated in two languages on every row fights that.

The motorcycle gloss went into the source row rather than the table
header: at eight columns that header has 1.55in and the Thai string
overflowed it. The fit checker caught it; this is what it is for.

Co-Authored-By: Claude Opus 5 <noreply@anthropic.com>
</commit_message>
<xml_diff>
--- a/docs/decks/mcom-2026-08-05-macro.pptx
+++ b/docs/decks/mcom-2026-08-05-macro.pptx
@@ -15921,7 +15921,7 @@
                           </a:solidFill>
                           <a:latin typeface="Kanit"/>
                         </a:rPr>
-                        <a:t>Pickup + PPV</a:t>
+                        <a:t>Pickup + PPV รถกระบะ</a:t>
                       </a:r>
                     </a:p>
                   </a:txBody>
@@ -16061,7 +16061,7 @@
                           </a:solidFill>
                           <a:latin typeface="Kanit"/>
                         </a:rPr>
-                        <a:t>Passenger car</a:t>
+                        <a:t>Passenger car รถยนต์นั่ง</a:t>
                       </a:r>
                     </a:p>
                   </a:txBody>
@@ -28806,7 +28806,7 @@
                 </a:solidFill>
                 <a:latin typeface="Kanit"/>
               </a:rPr>
-              <a:t>Pickup stock</a:t>
+              <a:t>Pickup stock รถกระบะ</a:t>
             </a:r>
           </a:p>
         </p:txBody>
@@ -28971,7 +28971,7 @@
                 </a:solidFill>
                 <a:latin typeface="Kanit"/>
               </a:rPr>
-              <a:t>Car stock</a:t>
+              <a:t>Car stock รถยนต์นั่ง</a:t>
             </a:r>
           </a:p>
         </p:txBody>
@@ -30651,7 +30651,7 @@
                 </a:solidFill>
                 <a:latin typeface="Kanit"/>
               </a:rPr>
-              <a:t>DLT registered stock and ownership transfers by region and class, plus MOT fleet totals. Share = class stock ÷ all registered vehicles in the region. Turnover = transfers ÷ registered stock — how much of the parc changes hands a year, the depth a repossessed title sells into.</a:t>
+              <a:t>DLT registered stock and ownership transfers by region and class (PU รถกระบะ · car รถยนต์นั่ง · moto รถจักรยานยนต์), plus MOT fleet totals. Share = class stock ÷ all registered vehicles in the region. Turnover = transfers ÷ registered stock — how much of the parc changes hands a year, the depth a repossessed title sells into.</a:t>
             </a:r>
           </a:p>
         </p:txBody>
@@ -34038,7 +34038,7 @@
                 </a:solidFill>
                 <a:latin typeface="Kanit"/>
               </a:rPr>
-              <a:t>Household debt</a:t>
+              <a:t>Household debt หนี้ครัวเรือน</a:t>
             </a:r>
           </a:p>
         </p:txBody>
@@ -34203,7 +34203,7 @@
                 </a:solidFill>
                 <a:latin typeface="Kanit"/>
               </a:rPr>
-              <a:t>Tourist arrivals</a:t>
+              <a:t>Tourist arrivals นักท่องเที่ยว</a:t>
             </a:r>
           </a:p>
         </p:txBody>
@@ -35674,7 +35674,7 @@
                 </a:solidFill>
                 <a:latin typeface="Kanit"/>
               </a:rPr>
-              <a:t>Thai banking-system NPL, % of loans · 40 quarters</a:t>
+              <a:t>Thai banking-system NPL หนี้เสีย, % of loans · 40 quarters</a:t>
             </a:r>
           </a:p>
         </p:txBody>
@@ -36514,7 +36514,7 @@
                 </a:solidFill>
                 <a:latin typeface="Kanit"/>
               </a:rPr>
-              <a:t>Labour force</a:t>
+              <a:t>Labour force กำลังแรงงาน</a:t>
             </a:r>
           </a:p>
         </p:txBody>
@@ -36679,7 +36679,7 @@
                 </a:solidFill>
                 <a:latin typeface="Kanit"/>
               </a:rPr>
-              <a:t>Informality</a:t>
+              <a:t>Informal work นอกระบบ</a:t>
             </a:r>
           </a:p>
         </p:txBody>
@@ -36844,7 +36844,7 @@
                 </a:solidFill>
                 <a:latin typeface="Kanit"/>
               </a:rPr>
-              <a:t>Vehicle fleet</a:t>
+              <a:t>Vehicle fleet รถจดทะเบียน</a:t>
             </a:r>
           </a:p>
         </p:txBody>
@@ -37009,7 +37009,7 @@
                 </a:solidFill>
                 <a:latin typeface="Kanit"/>
               </a:rPr>
-              <a:t>Districts dry</a:t>
+              <a:t>Districts dry ภัยแล้ง</a:t>
             </a:r>
           </a:p>
         </p:txBody>
@@ -37174,7 +37174,7 @@
                 </a:solidFill>
                 <a:latin typeface="Kanit"/>
               </a:rPr>
-              <a:t>Household debt</a:t>
+              <a:t>Household debt หนี้ครัวเรือน</a:t>
             </a:r>
           </a:p>
         </p:txBody>
@@ -37339,7 +37339,7 @@
                 </a:solidFill>
                 <a:latin typeface="Kanit"/>
               </a:rPr>
-              <a:t>No cushion</a:t>
+              <a:t>No cushion กันชนทางการเงิน</a:t>
             </a:r>
           </a:p>
         </p:txBody>

</xml_diff>